<commit_message>
Fix layout overflow and rendering issues across Ch09-Ch16
- Ch10 slide 12: replace garbled text with different CN wording
- Ch11 slides 6/8/10/11/12/13: shorten overflowing box content; fit h=3.55 budget
- Ch16 slide 5: reduce footer font 18→14 to avoid cut
- Ch16 slide 20: reduce title font 28→24 to prevent wrap
- Add qa_all/, qa_slides/, docs/, *.jpg to .gitignore

Co-Authored-By: Claude Opus 4.7 <noreply@anthropic.com>
</commit_message>
<xml_diff>
--- a/Ch03_Roman_Liturgy.pptx
+++ b/Ch03_Roman_Liturgy.pptx
@@ -2749,17 +2749,17 @@
         </p:nvSpPr>
         <p:spPr>
           <a:xfrm>
-            <a:off x="365760" y="1051560"/>
-            <a:ext cx="8412480" cy="594360"/>
-          </a:xfrm>
-          <a:prstGeom prst="rect">
-            <a:avLst/>
-          </a:prstGeom>
-          <a:noFill/>
-          <a:ln/>
-        </p:spPr>
-        <p:txBody>
-          <a:bodyPr wrap="square" rtlCol="0" anchor="t"/>
+            <a:off x="365760" y="1024128"/>
+            <a:ext cx="8412480" cy="804672"/>
+          </a:xfrm>
+          <a:prstGeom prst="rect">
+            <a:avLst/>
+          </a:prstGeom>
+          <a:noFill/>
+          <a:ln/>
+        </p:spPr>
+        <p:txBody>
+          <a:bodyPr wrap="square" lIns="0" tIns="0" rIns="0" bIns="0" rtlCol="0" anchor="t"/>
           <a:lstStyle/>
           <a:p>
             <a:pPr indent="0" marL="0">
@@ -2774,7 +2774,7 @@
                 <a:ea typeface="Calibri" pitchFamily="34" charset="-122"/>
                 <a:cs typeface="Calibri" pitchFamily="34" charset="-120"/>
               </a:rPr>
-              <a:t>Trope 的功能：在「授權聖詠」邊緣提供創作出口，類似中世紀學者在聖經邊註評論。文字增飾提供「釋義」（gloss），把聖詠文本與當日場合更緊密連結。</a:t>
+              <a:t>Trope 在「授權聖詠」邊緣提供創作出口；文字增飾提供「釋義」（gloss），把聖詠文本與當日場合更緊密連結。</a:t>
             </a:r>
             <a:endParaRPr lang="en-US" sz="1400" dirty="0"/>
           </a:p>
@@ -2791,7 +2791,7 @@
                 <a:ea typeface="Calibri" pitchFamily="34" charset="-122"/>
                 <a:cs typeface="Calibri" pitchFamily="34" charset="-120"/>
               </a:rPr>
-              <a:t>Tropes gave musicians creative outlets in the margins of the authorized repertory. Added words served as glosses, linking chant texts more closely to the occasion.</a:t>
+              <a:t>Tropes gave creative outlets in the margins of authorized chant; added words served as glosses linking chant to the occasion.</a:t>
             </a:r>
             <a:endParaRPr lang="en-US" sz="1400" dirty="0"/>
           </a:p>
@@ -2805,8 +2805,8 @@
         </p:nvSpPr>
         <p:spPr>
           <a:xfrm>
-            <a:off x="274320" y="1719072"/>
-            <a:ext cx="8595360" cy="914400"/>
+            <a:off x="274320" y="1901952"/>
+            <a:ext cx="8595360" cy="859536"/>
           </a:xfrm>
           <a:prstGeom prst="rect">
             <a:avLst/>
@@ -2825,7 +2825,7 @@
         </p:nvSpPr>
         <p:spPr>
           <a:xfrm>
-            <a:off x="411480" y="1792224"/>
+            <a:off x="411480" y="1965960"/>
             <a:ext cx="2377440" cy="274320"/>
           </a:xfrm>
           <a:prstGeom prst="rect">
@@ -2864,7 +2864,7 @@
         </p:nvSpPr>
         <p:spPr>
           <a:xfrm>
-            <a:off x="411480" y="2066544"/>
+            <a:off x="411480" y="2231136"/>
             <a:ext cx="2377440" cy="237744"/>
           </a:xfrm>
           <a:prstGeom prst="rect">
@@ -2903,8 +2903,8 @@
         </p:nvSpPr>
         <p:spPr>
           <a:xfrm>
-            <a:off x="2926080" y="1828800"/>
-            <a:ext cx="27432" cy="694944"/>
+            <a:off x="2926080" y="1993392"/>
+            <a:ext cx="27432" cy="676656"/>
           </a:xfrm>
           <a:prstGeom prst="rect">
             <a:avLst/>
@@ -2923,8 +2923,8 @@
         </p:nvSpPr>
         <p:spPr>
           <a:xfrm>
-            <a:off x="3017520" y="1792224"/>
-            <a:ext cx="3017520" cy="777240"/>
+            <a:off x="3017520" y="1956816"/>
+            <a:ext cx="3017520" cy="768096"/>
           </a:xfrm>
           <a:prstGeom prst="rect">
             <a:avLst/>
@@ -2982,7 +2982,7 @@
                 <a:ea typeface="Calibri" pitchFamily="34" charset="-122"/>
                 <a:cs typeface="Calibri" pitchFamily="34" charset="-120"/>
               </a:rPr>
-              <a:t>Before the chant or before each phrase</a:t>
+              <a:t>Before chant or each phrase</a:t>
             </a:r>
             <a:endParaRPr lang="en-US" sz="1400" dirty="0"/>
           </a:p>
@@ -2996,8 +2996,8 @@
         </p:nvSpPr>
         <p:spPr>
           <a:xfrm>
-            <a:off x="6080760" y="1792224"/>
-            <a:ext cx="2743200" cy="777240"/>
+            <a:off x="6080760" y="1956816"/>
+            <a:ext cx="2743200" cy="768096"/>
           </a:xfrm>
           <a:prstGeom prst="rect">
             <a:avLst/>
@@ -3021,7 +3021,7 @@
                 <a:ea typeface="Calibri" pitchFamily="34" charset="-122"/>
                 <a:cs typeface="Calibri" pitchFamily="34" charset="-120"/>
               </a:rPr>
-              <a:t>範例：Quem queritis in presepe（聖誕節 Introit 前的對話型 trope，late 10th c.）</a:t>
+              <a:t>範例：Quem queritis in presepe（聖誕節 Introit 前對話型 trope，late 10th c.）</a:t>
             </a:r>
             <a:endParaRPr lang="en-US" sz="1400" dirty="0"/>
           </a:p>
@@ -3035,8 +3035,8 @@
         </p:nvSpPr>
         <p:spPr>
           <a:xfrm>
-            <a:off x="274320" y="2743200"/>
-            <a:ext cx="8595360" cy="914400"/>
+            <a:off x="274320" y="2834640"/>
+            <a:ext cx="8595360" cy="859536"/>
           </a:xfrm>
           <a:prstGeom prst="rect">
             <a:avLst/>
@@ -3055,7 +3055,7 @@
         </p:nvSpPr>
         <p:spPr>
           <a:xfrm>
-            <a:off x="411480" y="2816352"/>
+            <a:off x="411480" y="2898648"/>
             <a:ext cx="2377440" cy="274320"/>
           </a:xfrm>
           <a:prstGeom prst="rect">
@@ -3094,7 +3094,7 @@
         </p:nvSpPr>
         <p:spPr>
           <a:xfrm>
-            <a:off x="411480" y="3090672"/>
+            <a:off x="411480" y="3163824"/>
             <a:ext cx="2377440" cy="237744"/>
           </a:xfrm>
           <a:prstGeom prst="rect">
@@ -3133,8 +3133,8 @@
         </p:nvSpPr>
         <p:spPr>
           <a:xfrm>
-            <a:off x="2926080" y="2852928"/>
-            <a:ext cx="27432" cy="694944"/>
+            <a:off x="2926080" y="2926080"/>
+            <a:ext cx="27432" cy="676656"/>
           </a:xfrm>
           <a:prstGeom prst="rect">
             <a:avLst/>
@@ -3153,8 +3153,8 @@
         </p:nvSpPr>
         <p:spPr>
           <a:xfrm>
-            <a:off x="3017520" y="2816352"/>
-            <a:ext cx="3017520" cy="777240"/>
+            <a:off x="3017520" y="2889504"/>
+            <a:ext cx="3017520" cy="768096"/>
           </a:xfrm>
           <a:prstGeom prst="rect">
             <a:avLst/>
@@ -3195,7 +3195,7 @@
                 <a:ea typeface="Calibri" pitchFamily="34" charset="-122"/>
                 <a:cs typeface="Calibri" pitchFamily="34" charset="-120"/>
               </a:rPr>
-              <a:t>Extending existing melismas or adding new ones</a:t>
+              <a:t>Extending or adding new melismas</a:t>
             </a:r>
             <a:endParaRPr lang="en-US" sz="1400" dirty="0"/>
           </a:p>
@@ -3209,8 +3209,8 @@
         </p:nvSpPr>
         <p:spPr>
           <a:xfrm>
-            <a:off x="6080760" y="2816352"/>
-            <a:ext cx="2743200" cy="777240"/>
+            <a:off x="6080760" y="2889504"/>
+            <a:ext cx="2743200" cy="768096"/>
           </a:xfrm>
           <a:prstGeom prst="rect">
             <a:avLst/>
@@ -3249,7 +3249,7 @@
         <p:spPr>
           <a:xfrm>
             <a:off x="274320" y="3767328"/>
-            <a:ext cx="8595360" cy="914400"/>
+            <a:ext cx="8595360" cy="859536"/>
           </a:xfrm>
           <a:prstGeom prst="rect">
             <a:avLst/>
@@ -3268,7 +3268,7 @@
         </p:nvSpPr>
         <p:spPr>
           <a:xfrm>
-            <a:off x="411480" y="3840480"/>
+            <a:off x="411480" y="3831336"/>
             <a:ext cx="2377440" cy="274320"/>
           </a:xfrm>
           <a:prstGeom prst="rect">
@@ -3307,7 +3307,7 @@
         </p:nvSpPr>
         <p:spPr>
           <a:xfrm>
-            <a:off x="411480" y="4114800"/>
+            <a:off x="411480" y="4096512"/>
             <a:ext cx="2377440" cy="237744"/>
           </a:xfrm>
           <a:prstGeom prst="rect">
@@ -3346,8 +3346,8 @@
         </p:nvSpPr>
         <p:spPr>
           <a:xfrm>
-            <a:off x="2926080" y="3877056"/>
-            <a:ext cx="27432" cy="694944"/>
+            <a:off x="2926080" y="3858768"/>
+            <a:ext cx="27432" cy="676656"/>
           </a:xfrm>
           <a:prstGeom prst="rect">
             <a:avLst/>
@@ -3366,8 +3366,8 @@
         </p:nvSpPr>
         <p:spPr>
           <a:xfrm>
-            <a:off x="3017520" y="3840480"/>
-            <a:ext cx="3017520" cy="777240"/>
+            <a:off x="3017520" y="3822192"/>
+            <a:ext cx="3017520" cy="768096"/>
           </a:xfrm>
           <a:prstGeom prst="rect">
             <a:avLst/>
@@ -3422,8 +3422,8 @@
         </p:nvSpPr>
         <p:spPr>
           <a:xfrm>
-            <a:off x="6080760" y="3840480"/>
-            <a:ext cx="2743200" cy="777240"/>
+            <a:off x="6080760" y="3822192"/>
+            <a:ext cx="2743200" cy="768096"/>
           </a:xfrm>
           <a:prstGeom prst="rect">
             <a:avLst/>
@@ -3447,7 +3447,7 @@
                 <a:ea typeface="Calibri" pitchFamily="34" charset="-122"/>
                 <a:cs typeface="Calibri" pitchFamily="34" charset="-120"/>
               </a:rPr>
-              <a:t>新詞的母音常模仿被取代音節的母音——產生迴響效果</a:t>
+              <a:t>新詞母音常模仿被取代音節的母音——迴響效果</a:t>
             </a:r>
             <a:endParaRPr lang="en-US" sz="1400" dirty="0"/>
           </a:p>
@@ -3461,17 +3461,17 @@
         </p:nvSpPr>
         <p:spPr>
           <a:xfrm>
-            <a:off x="365760" y="4754880"/>
-            <a:ext cx="8412480" cy="228600"/>
-          </a:xfrm>
-          <a:prstGeom prst="rect">
-            <a:avLst/>
-          </a:prstGeom>
-          <a:noFill/>
-          <a:ln/>
-        </p:spPr>
-        <p:txBody>
-          <a:bodyPr wrap="square" rtlCol="0" anchor="t"/>
+            <a:off x="365760" y="4736592"/>
+            <a:ext cx="8412480" cy="256032"/>
+          </a:xfrm>
+          <a:prstGeom prst="rect">
+            <a:avLst/>
+          </a:prstGeom>
+          <a:noFill/>
+          <a:ln/>
+        </p:spPr>
+        <p:txBody>
+          <a:bodyPr wrap="square" lIns="0" tIns="0" rIns="0" bIns="0" rtlCol="0" anchor="t"/>
           <a:lstStyle/>
           <a:p>
             <a:pPr algn="ctr" indent="0" marL="0">
@@ -3670,8 +3670,8 @@
         </p:nvSpPr>
         <p:spPr>
           <a:xfrm>
-            <a:off x="274320" y="1097280"/>
-            <a:ext cx="8595360" cy="1234440"/>
+            <a:off x="274320" y="1078992"/>
+            <a:ext cx="8595360" cy="877824"/>
           </a:xfrm>
           <a:prstGeom prst="rect">
             <a:avLst/>
@@ -3690,7 +3690,7 @@
         </p:nvSpPr>
         <p:spPr>
           <a:xfrm>
-            <a:off x="411480" y="1170432"/>
+            <a:off x="411480" y="1133856"/>
             <a:ext cx="8321040" cy="274320"/>
           </a:xfrm>
           <a:prstGeom prst="rect">
@@ -3700,7 +3700,7 @@
           <a:ln/>
         </p:spPr>
         <p:txBody>
-          <a:bodyPr wrap="square" rtlCol="0" anchor="ctr"/>
+          <a:bodyPr wrap="square" lIns="0" tIns="0" rIns="0" bIns="0" rtlCol="0" anchor="ctr"/>
           <a:lstStyle/>
           <a:p>
             <a:pPr indent="0" marL="0">
@@ -3729,17 +3729,17 @@
         </p:nvSpPr>
         <p:spPr>
           <a:xfrm>
-            <a:off x="457200" y="1463040"/>
-            <a:ext cx="8229600" cy="777240"/>
-          </a:xfrm>
-          <a:prstGeom prst="rect">
-            <a:avLst/>
-          </a:prstGeom>
-          <a:noFill/>
-          <a:ln/>
-        </p:spPr>
-        <p:txBody>
-          <a:bodyPr wrap="square" rtlCol="0" anchor="t"/>
+            <a:off x="457200" y="1408176"/>
+            <a:ext cx="8229600" cy="530352"/>
+          </a:xfrm>
+          <a:prstGeom prst="rect">
+            <a:avLst/>
+          </a:prstGeom>
+          <a:noFill/>
+          <a:ln/>
+        </p:spPr>
+        <p:txBody>
+          <a:bodyPr wrap="square" lIns="0" tIns="0" rIns="0" bIns="0" rtlCol="0" anchor="t"/>
           <a:lstStyle/>
           <a:p>
             <a:pPr indent="0" marL="0">
@@ -3754,7 +3754,7 @@
                 <a:ea typeface="Calibri" pitchFamily="34" charset="-122"/>
                 <a:cs typeface="Calibri" pitchFamily="34" charset="-120"/>
               </a:rPr>
-              <a:t>以音節式設定的詩句，多數成對（couplet）· 一對之內兩句音節數相同、共用同一旋律 · 每對新音樂、新歌詞</a:t>
+              <a:t>音節式詩句成對（couplet）；每對音節數相同、共用旋律；結構 A BB CC DD … N。</a:t>
             </a:r>
             <a:endParaRPr lang="en-US" sz="1400" dirty="0"/>
           </a:p>
@@ -3771,7 +3771,7 @@
                 <a:ea typeface="Calibri" pitchFamily="34" charset="-122"/>
                 <a:cs typeface="Calibri" pitchFamily="34" charset="-120"/>
               </a:rPr>
-              <a:t>結構：A BB CC DD … N（首末單獨詩句 + 中間成對詩句）· 與 Alleluia 之後的 sequentia 長花腔有歷史關聯</a:t>
+              <a:t>Strophic couplets of syllabic verse; structure A BB CC DD … N; derived from post-Alleluia sequentia.</a:t>
             </a:r>
             <a:endParaRPr lang="en-US" sz="1400" dirty="0"/>
           </a:p>
@@ -3785,8 +3785,8 @@
         </p:nvSpPr>
         <p:spPr>
           <a:xfrm>
-            <a:off x="274320" y="2450592"/>
-            <a:ext cx="8595360" cy="731520"/>
+            <a:off x="274320" y="2048256"/>
+            <a:ext cx="8595360" cy="786384"/>
           </a:xfrm>
           <a:prstGeom prst="rect">
             <a:avLst/>
@@ -3805,8 +3805,8 @@
         </p:nvSpPr>
         <p:spPr>
           <a:xfrm>
-            <a:off x="411480" y="2505456"/>
-            <a:ext cx="2377440" cy="594360"/>
+            <a:off x="411480" y="2103120"/>
+            <a:ext cx="2377440" cy="658368"/>
           </a:xfrm>
           <a:prstGeom prst="rect">
             <a:avLst/>
@@ -3861,7 +3861,7 @@
         </p:nvSpPr>
         <p:spPr>
           <a:xfrm>
-            <a:off x="2834640" y="2542032"/>
+            <a:off x="2834640" y="2139696"/>
             <a:ext cx="1188720" cy="274320"/>
           </a:xfrm>
           <a:prstGeom prst="rect">
@@ -3900,8 +3900,8 @@
         </p:nvSpPr>
         <p:spPr>
           <a:xfrm>
-            <a:off x="4069080" y="2560320"/>
-            <a:ext cx="27432" cy="502920"/>
+            <a:off x="4069080" y="2157984"/>
+            <a:ext cx="27432" cy="566928"/>
           </a:xfrm>
           <a:prstGeom prst="rect">
             <a:avLst/>
@@ -3920,8 +3920,8 @@
         </p:nvSpPr>
         <p:spPr>
           <a:xfrm>
-            <a:off x="4160520" y="2505456"/>
-            <a:ext cx="4663440" cy="640080"/>
+            <a:off x="4160520" y="2103120"/>
+            <a:ext cx="4663440" cy="713232"/>
           </a:xfrm>
           <a:prstGeom prst="rect">
             <a:avLst/>
@@ -3945,7 +3945,7 @@
                 <a:ea typeface="Calibri" pitchFamily="34" charset="-122"/>
                 <a:cs typeface="Calibri" pitchFamily="34" charset="-120"/>
               </a:rPr>
-              <a:t>聖加侖修道院的法蘭克修士；最著名的早期繼抒詠詞作者；884 完成《Liber hymnorum》</a:t>
+              <a:t>聖加侖修士；884《Liber hymnorum》</a:t>
             </a:r>
             <a:endParaRPr lang="en-US" sz="1400" dirty="0"/>
           </a:p>
@@ -3962,7 +3962,7 @@
                 <a:ea typeface="Calibri" pitchFamily="34" charset="-122"/>
                 <a:cs typeface="Calibri" pitchFamily="34" charset="-120"/>
               </a:rPr>
-              <a:t>Frankish monk at St. Gall; most famous early sequence writer; completed Liber hymnorum 884</a:t>
+              <a:t>St. Gall monk; famous early sequence composer</a:t>
             </a:r>
             <a:endParaRPr lang="en-US" sz="1400" dirty="0"/>
           </a:p>
@@ -3976,8 +3976,8 @@
         </p:nvSpPr>
         <p:spPr>
           <a:xfrm>
-            <a:off x="274320" y="3255264"/>
-            <a:ext cx="8595360" cy="731520"/>
+            <a:off x="274320" y="2907792"/>
+            <a:ext cx="8595360" cy="786384"/>
           </a:xfrm>
           <a:prstGeom prst="rect">
             <a:avLst/>
@@ -3996,8 +3996,8 @@
         </p:nvSpPr>
         <p:spPr>
           <a:xfrm>
-            <a:off x="411480" y="3310128"/>
-            <a:ext cx="2377440" cy="594360"/>
+            <a:off x="411480" y="2962656"/>
+            <a:ext cx="2377440" cy="658368"/>
           </a:xfrm>
           <a:prstGeom prst="rect">
             <a:avLst/>
@@ -4052,7 +4052,7 @@
         </p:nvSpPr>
         <p:spPr>
           <a:xfrm>
-            <a:off x="2834640" y="3346704"/>
+            <a:off x="2834640" y="2999232"/>
             <a:ext cx="1188720" cy="274320"/>
           </a:xfrm>
           <a:prstGeom prst="rect">
@@ -4091,8 +4091,8 @@
         </p:nvSpPr>
         <p:spPr>
           <a:xfrm>
-            <a:off x="4069080" y="3364992"/>
-            <a:ext cx="27432" cy="502920"/>
+            <a:off x="4069080" y="3017520"/>
+            <a:ext cx="27432" cy="566928"/>
           </a:xfrm>
           <a:prstGeom prst="rect">
             <a:avLst/>
@@ -4111,8 +4111,8 @@
         </p:nvSpPr>
         <p:spPr>
           <a:xfrm>
-            <a:off x="4160520" y="3310128"/>
-            <a:ext cx="4663440" cy="640080"/>
+            <a:off x="4160520" y="2962656"/>
+            <a:ext cx="4663440" cy="713232"/>
           </a:xfrm>
           <a:prstGeom prst="rect">
             <a:avLst/>
@@ -4136,7 +4136,7 @@
                 <a:ea typeface="Calibri" pitchFamily="34" charset="-122"/>
                 <a:cs typeface="Calibri" pitchFamily="34" charset="-120"/>
               </a:rPr>
-              <a:t>神聖羅馬皇帝的宮廷牧師；創作 Victimae paschali laudes（復活節繼抒詠）——現存四首仍被保留的古繼抒詠之一</a:t>
+              <a:t>神聖羅馬皇帝宮廷牧師；Victimae paschali laudes（復活節）</a:t>
             </a:r>
             <a:endParaRPr lang="en-US" sz="1400" dirty="0"/>
           </a:p>
@@ -4153,7 +4153,7 @@
                 <a:ea typeface="Calibri" pitchFamily="34" charset="-122"/>
                 <a:cs typeface="Calibri" pitchFamily="34" charset="-120"/>
               </a:rPr>
-              <a:t>Imperial chaplain; composed Victimae paschali laudes (Easter)</a:t>
+              <a:t>Imperial chaplain; Victimae paschali laudes (Easter)</a:t>
             </a:r>
             <a:endParaRPr lang="en-US" sz="1400" dirty="0"/>
           </a:p>
@@ -4167,8 +4167,8 @@
         </p:nvSpPr>
         <p:spPr>
           <a:xfrm>
-            <a:off x="274320" y="4059936"/>
-            <a:ext cx="8595360" cy="731520"/>
+            <a:off x="274320" y="3767328"/>
+            <a:ext cx="8595360" cy="786384"/>
           </a:xfrm>
           <a:prstGeom prst="rect">
             <a:avLst/>
@@ -4187,8 +4187,8 @@
         </p:nvSpPr>
         <p:spPr>
           <a:xfrm>
-            <a:off x="411480" y="4114800"/>
-            <a:ext cx="2377440" cy="594360"/>
+            <a:off x="411480" y="3822192"/>
+            <a:ext cx="2377440" cy="658368"/>
           </a:xfrm>
           <a:prstGeom prst="rect">
             <a:avLst/>
@@ -4243,7 +4243,7 @@
         </p:nvSpPr>
         <p:spPr>
           <a:xfrm>
-            <a:off x="2834640" y="4151376"/>
+            <a:off x="2834640" y="3858768"/>
             <a:ext cx="1188720" cy="274320"/>
           </a:xfrm>
           <a:prstGeom prst="rect">
@@ -4282,8 +4282,8 @@
         </p:nvSpPr>
         <p:spPr>
           <a:xfrm>
-            <a:off x="4069080" y="4169664"/>
-            <a:ext cx="27432" cy="502920"/>
+            <a:off x="4069080" y="3877056"/>
+            <a:ext cx="27432" cy="566928"/>
           </a:xfrm>
           <a:prstGeom prst="rect">
             <a:avLst/>
@@ -4302,8 +4302,8 @@
         </p:nvSpPr>
         <p:spPr>
           <a:xfrm>
-            <a:off x="4160520" y="4114800"/>
-            <a:ext cx="4663440" cy="640080"/>
+            <a:off x="4160520" y="3822192"/>
+            <a:ext cx="4663440" cy="713232"/>
           </a:xfrm>
           <a:prstGeom prst="rect">
             <a:avLst/>
@@ -4327,7 +4327,7 @@
                 <a:ea typeface="Calibri" pitchFamily="34" charset="-122"/>
                 <a:cs typeface="Calibri" pitchFamily="34" charset="-120"/>
               </a:rPr>
-              <a:t>聖方濟各的傳記作者；創作 Dies irae（末日經）——中世紀最著名詩作之一；形式 AA BB CC / AA BB CC / AA BB C / D E</a:t>
+              <a:t>聖方濟各傳記作者；Dies irae——中世紀名詩</a:t>
             </a:r>
             <a:endParaRPr lang="en-US" sz="1400" dirty="0"/>
           </a:p>
@@ -4344,7 +4344,7 @@
                 <a:ea typeface="Calibri" pitchFamily="34" charset="-122"/>
                 <a:cs typeface="Calibri" pitchFamily="34" charset="-120"/>
               </a:rPr>
-              <a:t>Biographer of St. Francis; composed Dies irae — one of the most famous poems of the Middle Ages</a:t>
+              <a:t>Biographer of St. Francis; composed Dies irae</a:t>
             </a:r>
             <a:endParaRPr lang="en-US" sz="1400" dirty="0"/>
           </a:p>
@@ -4358,17 +4358,17 @@
         </p:nvSpPr>
         <p:spPr>
           <a:xfrm>
-            <a:off x="365760" y="4809744"/>
-            <a:ext cx="8412480" cy="201168"/>
-          </a:xfrm>
-          <a:prstGeom prst="rect">
-            <a:avLst/>
-          </a:prstGeom>
-          <a:noFill/>
-          <a:ln/>
-        </p:spPr>
-        <p:txBody>
-          <a:bodyPr wrap="square" rtlCol="0" anchor="t"/>
+            <a:off x="365760" y="4736592"/>
+            <a:ext cx="8412480" cy="256032"/>
+          </a:xfrm>
+          <a:prstGeom prst="rect">
+            <a:avLst/>
+          </a:prstGeom>
+          <a:noFill/>
+          <a:ln/>
+        </p:spPr>
+        <p:txBody>
+          <a:bodyPr wrap="square" lIns="0" tIns="0" rIns="0" bIns="0" rtlCol="0" anchor="t"/>
           <a:lstStyle/>
           <a:p>
             <a:pPr algn="ctr" indent="0" marL="0">
@@ -5810,8 +5810,8 @@
         </p:nvSpPr>
         <p:spPr>
           <a:xfrm>
-            <a:off x="2377440" y="777240"/>
-            <a:ext cx="45720" cy="4160520"/>
+            <a:off x="2377440" y="749808"/>
+            <a:ext cx="45720" cy="4069080"/>
           </a:xfrm>
           <a:prstGeom prst="rect">
             <a:avLst/>
@@ -5830,8 +5830,8 @@
         </p:nvSpPr>
         <p:spPr>
           <a:xfrm>
-            <a:off x="2258568" y="813816"/>
-            <a:ext cx="237744" cy="237744"/>
+            <a:off x="2258568" y="768096"/>
+            <a:ext cx="219456" cy="219456"/>
           </a:xfrm>
           <a:prstGeom prst="ellipse">
             <a:avLst/>
@@ -5850,8 +5850,8 @@
         </p:nvSpPr>
         <p:spPr>
           <a:xfrm>
-            <a:off x="91440" y="777240"/>
-            <a:ext cx="2084832" cy="256032"/>
+            <a:off x="91440" y="749808"/>
+            <a:ext cx="2084832" cy="237744"/>
           </a:xfrm>
           <a:prstGeom prst="rect">
             <a:avLst/>
@@ -5889,8 +5889,8 @@
         </p:nvSpPr>
         <p:spPr>
           <a:xfrm>
-            <a:off x="2670048" y="777240"/>
-            <a:ext cx="6217920" cy="256032"/>
+            <a:off x="2670048" y="749808"/>
+            <a:ext cx="6217920" cy="237744"/>
           </a:xfrm>
           <a:prstGeom prst="rect">
             <a:avLst/>
@@ -5928,8 +5928,8 @@
         </p:nvSpPr>
         <p:spPr>
           <a:xfrm>
-            <a:off x="2258568" y="1074420"/>
-            <a:ext cx="237744" cy="237744"/>
+            <a:off x="2258568" y="1019556"/>
+            <a:ext cx="219456" cy="219456"/>
           </a:xfrm>
           <a:prstGeom prst="ellipse">
             <a:avLst/>
@@ -5948,8 +5948,8 @@
         </p:nvSpPr>
         <p:spPr>
           <a:xfrm>
-            <a:off x="91440" y="1037844"/>
-            <a:ext cx="2084832" cy="256032"/>
+            <a:off x="91440" y="1001268"/>
+            <a:ext cx="2084832" cy="237744"/>
           </a:xfrm>
           <a:prstGeom prst="rect">
             <a:avLst/>
@@ -5987,8 +5987,8 @@
         </p:nvSpPr>
         <p:spPr>
           <a:xfrm>
-            <a:off x="2670048" y="1037844"/>
-            <a:ext cx="6217920" cy="256032"/>
+            <a:off x="2670048" y="1001268"/>
+            <a:ext cx="6217920" cy="237744"/>
           </a:xfrm>
           <a:prstGeom prst="rect">
             <a:avLst/>
@@ -6026,8 +6026,8 @@
         </p:nvSpPr>
         <p:spPr>
           <a:xfrm>
-            <a:off x="2258568" y="1335024"/>
-            <a:ext cx="237744" cy="237744"/>
+            <a:off x="2258568" y="1271016"/>
+            <a:ext cx="219456" cy="219456"/>
           </a:xfrm>
           <a:prstGeom prst="ellipse">
             <a:avLst/>
@@ -6046,8 +6046,8 @@
         </p:nvSpPr>
         <p:spPr>
           <a:xfrm>
-            <a:off x="91440" y="1298448"/>
-            <a:ext cx="2084832" cy="256032"/>
+            <a:off x="91440" y="1252728"/>
+            <a:ext cx="2084832" cy="237744"/>
           </a:xfrm>
           <a:prstGeom prst="rect">
             <a:avLst/>
@@ -6085,8 +6085,8 @@
         </p:nvSpPr>
         <p:spPr>
           <a:xfrm>
-            <a:off x="2670048" y="1298448"/>
-            <a:ext cx="6217920" cy="256032"/>
+            <a:off x="2670048" y="1252728"/>
+            <a:ext cx="6217920" cy="237744"/>
           </a:xfrm>
           <a:prstGeom prst="rect">
             <a:avLst/>
@@ -6124,8 +6124,8 @@
         </p:nvSpPr>
         <p:spPr>
           <a:xfrm>
-            <a:off x="2258568" y="1595628"/>
-            <a:ext cx="237744" cy="237744"/>
+            <a:off x="2258568" y="1522476"/>
+            <a:ext cx="219456" cy="219456"/>
           </a:xfrm>
           <a:prstGeom prst="ellipse">
             <a:avLst/>
@@ -6144,8 +6144,8 @@
         </p:nvSpPr>
         <p:spPr>
           <a:xfrm>
-            <a:off x="91440" y="1559052"/>
-            <a:ext cx="2084832" cy="256032"/>
+            <a:off x="91440" y="1504188"/>
+            <a:ext cx="2084832" cy="237744"/>
           </a:xfrm>
           <a:prstGeom prst="rect">
             <a:avLst/>
@@ -6183,8 +6183,8 @@
         </p:nvSpPr>
         <p:spPr>
           <a:xfrm>
-            <a:off x="2670048" y="1559052"/>
-            <a:ext cx="6217920" cy="256032"/>
+            <a:off x="2670048" y="1504188"/>
+            <a:ext cx="6217920" cy="237744"/>
           </a:xfrm>
           <a:prstGeom prst="rect">
             <a:avLst/>
@@ -6222,8 +6222,8 @@
         </p:nvSpPr>
         <p:spPr>
           <a:xfrm>
-            <a:off x="2258568" y="1856232"/>
-            <a:ext cx="237744" cy="237744"/>
+            <a:off x="2258568" y="1773936"/>
+            <a:ext cx="219456" cy="219456"/>
           </a:xfrm>
           <a:prstGeom prst="ellipse">
             <a:avLst/>
@@ -6242,8 +6242,8 @@
         </p:nvSpPr>
         <p:spPr>
           <a:xfrm>
-            <a:off x="91440" y="1819656"/>
-            <a:ext cx="2084832" cy="256032"/>
+            <a:off x="91440" y="1755648"/>
+            <a:ext cx="2084832" cy="237744"/>
           </a:xfrm>
           <a:prstGeom prst="rect">
             <a:avLst/>
@@ -6281,8 +6281,8 @@
         </p:nvSpPr>
         <p:spPr>
           <a:xfrm>
-            <a:off x="2670048" y="1819656"/>
-            <a:ext cx="6217920" cy="256032"/>
+            <a:off x="2670048" y="1755648"/>
+            <a:ext cx="6217920" cy="237744"/>
           </a:xfrm>
           <a:prstGeom prst="rect">
             <a:avLst/>
@@ -6320,8 +6320,8 @@
         </p:nvSpPr>
         <p:spPr>
           <a:xfrm>
-            <a:off x="2258568" y="2116836"/>
-            <a:ext cx="237744" cy="237744"/>
+            <a:off x="2258568" y="2025396"/>
+            <a:ext cx="219456" cy="219456"/>
           </a:xfrm>
           <a:prstGeom prst="ellipse">
             <a:avLst/>
@@ -6340,8 +6340,8 @@
         </p:nvSpPr>
         <p:spPr>
           <a:xfrm>
-            <a:off x="91440" y="2080260"/>
-            <a:ext cx="2084832" cy="256032"/>
+            <a:off x="91440" y="2007108"/>
+            <a:ext cx="2084832" cy="237744"/>
           </a:xfrm>
           <a:prstGeom prst="rect">
             <a:avLst/>
@@ -6379,8 +6379,8 @@
         </p:nvSpPr>
         <p:spPr>
           <a:xfrm>
-            <a:off x="2670048" y="2080260"/>
-            <a:ext cx="6217920" cy="256032"/>
+            <a:off x="2670048" y="2007108"/>
+            <a:ext cx="6217920" cy="237744"/>
           </a:xfrm>
           <a:prstGeom prst="rect">
             <a:avLst/>
@@ -6418,8 +6418,8 @@
         </p:nvSpPr>
         <p:spPr>
           <a:xfrm>
-            <a:off x="2258568" y="2377440"/>
-            <a:ext cx="237744" cy="237744"/>
+            <a:off x="2258568" y="2276856"/>
+            <a:ext cx="219456" cy="219456"/>
           </a:xfrm>
           <a:prstGeom prst="ellipse">
             <a:avLst/>
@@ -6438,8 +6438,8 @@
         </p:nvSpPr>
         <p:spPr>
           <a:xfrm>
-            <a:off x="91440" y="2340864"/>
-            <a:ext cx="2084832" cy="256032"/>
+            <a:off x="91440" y="2258568"/>
+            <a:ext cx="2084832" cy="237744"/>
           </a:xfrm>
           <a:prstGeom prst="rect">
             <a:avLst/>
@@ -6477,8 +6477,8 @@
         </p:nvSpPr>
         <p:spPr>
           <a:xfrm>
-            <a:off x="2670048" y="2340864"/>
-            <a:ext cx="6217920" cy="256032"/>
+            <a:off x="2670048" y="2258568"/>
+            <a:ext cx="6217920" cy="237744"/>
           </a:xfrm>
           <a:prstGeom prst="rect">
             <a:avLst/>
@@ -6516,8 +6516,8 @@
         </p:nvSpPr>
         <p:spPr>
           <a:xfrm>
-            <a:off x="2258568" y="2638044"/>
-            <a:ext cx="237744" cy="237744"/>
+            <a:off x="2258568" y="2528316"/>
+            <a:ext cx="219456" cy="219456"/>
           </a:xfrm>
           <a:prstGeom prst="ellipse">
             <a:avLst/>
@@ -6536,8 +6536,8 @@
         </p:nvSpPr>
         <p:spPr>
           <a:xfrm>
-            <a:off x="91440" y="2601468"/>
-            <a:ext cx="2084832" cy="256032"/>
+            <a:off x="91440" y="2510028"/>
+            <a:ext cx="2084832" cy="237744"/>
           </a:xfrm>
           <a:prstGeom prst="rect">
             <a:avLst/>
@@ -6575,8 +6575,8 @@
         </p:nvSpPr>
         <p:spPr>
           <a:xfrm>
-            <a:off x="2670048" y="2601468"/>
-            <a:ext cx="6217920" cy="256032"/>
+            <a:off x="2670048" y="2510028"/>
+            <a:ext cx="6217920" cy="237744"/>
           </a:xfrm>
           <a:prstGeom prst="rect">
             <a:avLst/>
@@ -6614,8 +6614,8 @@
         </p:nvSpPr>
         <p:spPr>
           <a:xfrm>
-            <a:off x="2258568" y="2898648"/>
-            <a:ext cx="237744" cy="237744"/>
+            <a:off x="2258568" y="2779776"/>
+            <a:ext cx="219456" cy="219456"/>
           </a:xfrm>
           <a:prstGeom prst="ellipse">
             <a:avLst/>
@@ -6634,8 +6634,8 @@
         </p:nvSpPr>
         <p:spPr>
           <a:xfrm>
-            <a:off x="91440" y="2862072"/>
-            <a:ext cx="2084832" cy="256032"/>
+            <a:off x="91440" y="2761488"/>
+            <a:ext cx="2084832" cy="237744"/>
           </a:xfrm>
           <a:prstGeom prst="rect">
             <a:avLst/>
@@ -6673,8 +6673,8 @@
         </p:nvSpPr>
         <p:spPr>
           <a:xfrm>
-            <a:off x="2670048" y="2862072"/>
-            <a:ext cx="6217920" cy="256032"/>
+            <a:off x="2670048" y="2761488"/>
+            <a:ext cx="6217920" cy="237744"/>
           </a:xfrm>
           <a:prstGeom prst="rect">
             <a:avLst/>
@@ -6712,8 +6712,8 @@
         </p:nvSpPr>
         <p:spPr>
           <a:xfrm>
-            <a:off x="2258568" y="3159252"/>
-            <a:ext cx="237744" cy="237744"/>
+            <a:off x="2258568" y="3031236"/>
+            <a:ext cx="219456" cy="219456"/>
           </a:xfrm>
           <a:prstGeom prst="ellipse">
             <a:avLst/>
@@ -6732,8 +6732,8 @@
         </p:nvSpPr>
         <p:spPr>
           <a:xfrm>
-            <a:off x="91440" y="3122676"/>
-            <a:ext cx="2084832" cy="256032"/>
+            <a:off x="91440" y="3012948"/>
+            <a:ext cx="2084832" cy="237744"/>
           </a:xfrm>
           <a:prstGeom prst="rect">
             <a:avLst/>
@@ -6771,8 +6771,8 @@
         </p:nvSpPr>
         <p:spPr>
           <a:xfrm>
-            <a:off x="2670048" y="3122676"/>
-            <a:ext cx="6217920" cy="256032"/>
+            <a:off x="2670048" y="3012948"/>
+            <a:ext cx="6217920" cy="237744"/>
           </a:xfrm>
           <a:prstGeom prst="rect">
             <a:avLst/>
@@ -6810,8 +6810,8 @@
         </p:nvSpPr>
         <p:spPr>
           <a:xfrm>
-            <a:off x="2258568" y="3419856"/>
-            <a:ext cx="237744" cy="237744"/>
+            <a:off x="2258568" y="3282696"/>
+            <a:ext cx="219456" cy="219456"/>
           </a:xfrm>
           <a:prstGeom prst="ellipse">
             <a:avLst/>
@@ -6830,8 +6830,8 @@
         </p:nvSpPr>
         <p:spPr>
           <a:xfrm>
-            <a:off x="91440" y="3383280"/>
-            <a:ext cx="2084832" cy="256032"/>
+            <a:off x="91440" y="3264408"/>
+            <a:ext cx="2084832" cy="237744"/>
           </a:xfrm>
           <a:prstGeom prst="rect">
             <a:avLst/>
@@ -6869,8 +6869,8 @@
         </p:nvSpPr>
         <p:spPr>
           <a:xfrm>
-            <a:off x="2670048" y="3383280"/>
-            <a:ext cx="6217920" cy="256032"/>
+            <a:off x="2670048" y="3264408"/>
+            <a:ext cx="6217920" cy="237744"/>
           </a:xfrm>
           <a:prstGeom prst="rect">
             <a:avLst/>
@@ -6908,8 +6908,8 @@
         </p:nvSpPr>
         <p:spPr>
           <a:xfrm>
-            <a:off x="2258568" y="3680460"/>
-            <a:ext cx="237744" cy="237744"/>
+            <a:off x="2258568" y="3534156"/>
+            <a:ext cx="219456" cy="219456"/>
           </a:xfrm>
           <a:prstGeom prst="ellipse">
             <a:avLst/>
@@ -6928,8 +6928,8 @@
         </p:nvSpPr>
         <p:spPr>
           <a:xfrm>
-            <a:off x="91440" y="3643884"/>
-            <a:ext cx="2084832" cy="256032"/>
+            <a:off x="91440" y="3515868"/>
+            <a:ext cx="2084832" cy="237744"/>
           </a:xfrm>
           <a:prstGeom prst="rect">
             <a:avLst/>
@@ -6967,8 +6967,8 @@
         </p:nvSpPr>
         <p:spPr>
           <a:xfrm>
-            <a:off x="2670048" y="3643884"/>
-            <a:ext cx="6217920" cy="256032"/>
+            <a:off x="2670048" y="3515868"/>
+            <a:ext cx="6217920" cy="237744"/>
           </a:xfrm>
           <a:prstGeom prst="rect">
             <a:avLst/>
@@ -7006,8 +7006,8 @@
         </p:nvSpPr>
         <p:spPr>
           <a:xfrm>
-            <a:off x="2258568" y="3941064"/>
-            <a:ext cx="237744" cy="237744"/>
+            <a:off x="2258568" y="3785616"/>
+            <a:ext cx="219456" cy="219456"/>
           </a:xfrm>
           <a:prstGeom prst="ellipse">
             <a:avLst/>
@@ -7026,8 +7026,8 @@
         </p:nvSpPr>
         <p:spPr>
           <a:xfrm>
-            <a:off x="91440" y="3904488"/>
-            <a:ext cx="2084832" cy="256032"/>
+            <a:off x="91440" y="3767328"/>
+            <a:ext cx="2084832" cy="237744"/>
           </a:xfrm>
           <a:prstGeom prst="rect">
             <a:avLst/>
@@ -7065,8 +7065,8 @@
         </p:nvSpPr>
         <p:spPr>
           <a:xfrm>
-            <a:off x="2670048" y="3904488"/>
-            <a:ext cx="6217920" cy="256032"/>
+            <a:off x="2670048" y="3767328"/>
+            <a:ext cx="6217920" cy="237744"/>
           </a:xfrm>
           <a:prstGeom prst="rect">
             <a:avLst/>
@@ -7104,8 +7104,8 @@
         </p:nvSpPr>
         <p:spPr>
           <a:xfrm>
-            <a:off x="2258568" y="4201668"/>
-            <a:ext cx="237744" cy="237744"/>
+            <a:off x="2258568" y="4037076"/>
+            <a:ext cx="219456" cy="219456"/>
           </a:xfrm>
           <a:prstGeom prst="ellipse">
             <a:avLst/>
@@ -7124,8 +7124,8 @@
         </p:nvSpPr>
         <p:spPr>
           <a:xfrm>
-            <a:off x="91440" y="4165092"/>
-            <a:ext cx="2084832" cy="256032"/>
+            <a:off x="91440" y="4018788"/>
+            <a:ext cx="2084832" cy="237744"/>
           </a:xfrm>
           <a:prstGeom prst="rect">
             <a:avLst/>
@@ -7163,8 +7163,8 @@
         </p:nvSpPr>
         <p:spPr>
           <a:xfrm>
-            <a:off x="2670048" y="4165092"/>
-            <a:ext cx="6217920" cy="256032"/>
+            <a:off x="2670048" y="4018788"/>
+            <a:ext cx="6217920" cy="237744"/>
           </a:xfrm>
           <a:prstGeom prst="rect">
             <a:avLst/>
@@ -7202,8 +7202,8 @@
         </p:nvSpPr>
         <p:spPr>
           <a:xfrm>
-            <a:off x="2258568" y="4462272"/>
-            <a:ext cx="237744" cy="237744"/>
+            <a:off x="2258568" y="4288536"/>
+            <a:ext cx="219456" cy="219456"/>
           </a:xfrm>
           <a:prstGeom prst="ellipse">
             <a:avLst/>
@@ -7222,8 +7222,8 @@
         </p:nvSpPr>
         <p:spPr>
           <a:xfrm>
-            <a:off x="91440" y="4425696"/>
-            <a:ext cx="2084832" cy="256032"/>
+            <a:off x="91440" y="4270248"/>
+            <a:ext cx="2084832" cy="237744"/>
           </a:xfrm>
           <a:prstGeom prst="rect">
             <a:avLst/>
@@ -7261,8 +7261,8 @@
         </p:nvSpPr>
         <p:spPr>
           <a:xfrm>
-            <a:off x="2670048" y="4425696"/>
-            <a:ext cx="6217920" cy="256032"/>
+            <a:off x="2670048" y="4270248"/>
+            <a:ext cx="6217920" cy="237744"/>
           </a:xfrm>
           <a:prstGeom prst="rect">
             <a:avLst/>
@@ -7300,8 +7300,8 @@
         </p:nvSpPr>
         <p:spPr>
           <a:xfrm>
-            <a:off x="2258568" y="4722876"/>
-            <a:ext cx="237744" cy="237744"/>
+            <a:off x="2258568" y="4539996"/>
+            <a:ext cx="219456" cy="219456"/>
           </a:xfrm>
           <a:prstGeom prst="ellipse">
             <a:avLst/>
@@ -7320,8 +7320,8 @@
         </p:nvSpPr>
         <p:spPr>
           <a:xfrm>
-            <a:off x="91440" y="4686300"/>
-            <a:ext cx="2084832" cy="256032"/>
+            <a:off x="91440" y="4521708"/>
+            <a:ext cx="2084832" cy="237744"/>
           </a:xfrm>
           <a:prstGeom prst="rect">
             <a:avLst/>
@@ -7359,8 +7359,8 @@
         </p:nvSpPr>
         <p:spPr>
           <a:xfrm>
-            <a:off x="2670048" y="4686300"/>
-            <a:ext cx="6217920" cy="256032"/>
+            <a:off x="2670048" y="4521708"/>
+            <a:ext cx="6217920" cy="237744"/>
           </a:xfrm>
           <a:prstGeom prst="rect">
             <a:avLst/>
@@ -7384,7 +7384,7 @@
                 <a:ea typeface="Calibri" pitchFamily="34" charset="-122"/>
                 <a:cs typeface="Calibri" pitchFamily="34" charset="-120"/>
               </a:rPr>
-              <a:t>特倫多會議禁用大多數 trope 與 sequence · Council of Trent bans tropes, most sequences</a:t>
+              <a:t>特倫多會議禁用大多數 trope 與 sequence · Trent bans most tropes/sequences</a:t>
             </a:r>
             <a:endParaRPr lang="en-US" sz="1400" dirty="0"/>
           </a:p>
@@ -7568,7 +7568,7 @@
         </p:nvSpPr>
         <p:spPr>
           <a:xfrm>
-            <a:off x="274320" y="1078992"/>
+            <a:off x="274320" y="1051560"/>
             <a:ext cx="8595360" cy="841248"/>
           </a:xfrm>
           <a:prstGeom prst="rect">
@@ -7588,7 +7588,7 @@
         </p:nvSpPr>
         <p:spPr>
           <a:xfrm>
-            <a:off x="365760" y="1152144"/>
+            <a:off x="365760" y="1124712"/>
             <a:ext cx="685800" cy="694944"/>
           </a:xfrm>
           <a:prstGeom prst="rect">
@@ -7608,7 +7608,7 @@
         </p:nvSpPr>
         <p:spPr>
           <a:xfrm>
-            <a:off x="365760" y="1207008"/>
+            <a:off x="365760" y="1179576"/>
             <a:ext cx="685800" cy="594360"/>
           </a:xfrm>
           <a:prstGeom prst="rect">
@@ -7644,7 +7644,7 @@
         </p:nvSpPr>
         <p:spPr>
           <a:xfrm>
-            <a:off x="1188720" y="1143000"/>
+            <a:off x="1188720" y="1115568"/>
             <a:ext cx="3200400" cy="274320"/>
           </a:xfrm>
           <a:prstGeom prst="rect">
@@ -7683,7 +7683,7 @@
         </p:nvSpPr>
         <p:spPr>
           <a:xfrm>
-            <a:off x="1188720" y="1389888"/>
+            <a:off x="1188720" y="1362456"/>
             <a:ext cx="3200400" cy="228600"/>
           </a:xfrm>
           <a:prstGeom prst="rect">
@@ -7722,7 +7722,7 @@
         </p:nvSpPr>
         <p:spPr>
           <a:xfrm>
-            <a:off x="4434840" y="1188720"/>
+            <a:off x="4434840" y="1161288"/>
             <a:ext cx="27432" cy="621792"/>
           </a:xfrm>
           <a:prstGeom prst="rect">
@@ -7742,8 +7742,8 @@
         </p:nvSpPr>
         <p:spPr>
           <a:xfrm>
-            <a:off x="4526280" y="1152144"/>
-            <a:ext cx="4297680" cy="731520"/>
+            <a:off x="4526280" y="1106424"/>
+            <a:ext cx="4297680" cy="768096"/>
           </a:xfrm>
           <a:prstGeom prst="rect">
             <a:avLst/>
@@ -7767,7 +7767,7 @@
                 <a:ea typeface="Calibri" pitchFamily="34" charset="-122"/>
                 <a:cs typeface="Calibri" pitchFamily="34" charset="-120"/>
               </a:rPr>
-              <a:t>Léonin、Du Fay、Ockeghem、Josquin、Palestrina 等作曲家主要工作是演唱和指揮聖詠；多聲部音樂以聖詠為基礎發展</a:t>
+              <a:t>Léonin、Du Fay、Josquin、Palestrina 等作曲家主要工作是演唱和指揮聖詠</a:t>
             </a:r>
             <a:endParaRPr lang="en-US" sz="1400" dirty="0"/>
           </a:p>
@@ -7784,7 +7784,7 @@
                 <a:ea typeface="Calibri" pitchFamily="34" charset="-122"/>
                 <a:cs typeface="Calibri" pitchFamily="34" charset="-120"/>
               </a:rPr>
-              <a:t>Major composers spent most of their time singing and directing chant; polyphony built on chant foundation</a:t>
+              <a:t>Major composers spent most of their time singing and directing chant</a:t>
             </a:r>
             <a:endParaRPr lang="en-US" sz="1400" dirty="0"/>
           </a:p>
@@ -7798,7 +7798,7 @@
         </p:nvSpPr>
         <p:spPr>
           <a:xfrm>
-            <a:off x="274320" y="2020824"/>
+            <a:off x="274320" y="1984248"/>
             <a:ext cx="8595360" cy="841248"/>
           </a:xfrm>
           <a:prstGeom prst="rect">
@@ -7818,7 +7818,7 @@
         </p:nvSpPr>
         <p:spPr>
           <a:xfrm>
-            <a:off x="365760" y="2093976"/>
+            <a:off x="365760" y="2057400"/>
             <a:ext cx="685800" cy="694944"/>
           </a:xfrm>
           <a:prstGeom prst="rect">
@@ -7838,7 +7838,7 @@
         </p:nvSpPr>
         <p:spPr>
           <a:xfrm>
-            <a:off x="365760" y="2148840"/>
+            <a:off x="365760" y="2112264"/>
             <a:ext cx="685800" cy="594360"/>
           </a:xfrm>
           <a:prstGeom prst="rect">
@@ -7874,7 +7874,7 @@
         </p:nvSpPr>
         <p:spPr>
           <a:xfrm>
-            <a:off x="1188720" y="2084832"/>
+            <a:off x="1188720" y="2048256"/>
             <a:ext cx="3200400" cy="274320"/>
           </a:xfrm>
           <a:prstGeom prst="rect">
@@ -7913,7 +7913,7 @@
         </p:nvSpPr>
         <p:spPr>
           <a:xfrm>
-            <a:off x="1188720" y="2331720"/>
+            <a:off x="1188720" y="2295144"/>
             <a:ext cx="3200400" cy="228600"/>
           </a:xfrm>
           <a:prstGeom prst="rect">
@@ -7952,7 +7952,7 @@
         </p:nvSpPr>
         <p:spPr>
           <a:xfrm>
-            <a:off x="4434840" y="2130552"/>
+            <a:off x="4434840" y="2093976"/>
             <a:ext cx="27432" cy="621792"/>
           </a:xfrm>
           <a:prstGeom prst="rect">
@@ -7972,8 +7972,8 @@
         </p:nvSpPr>
         <p:spPr>
           <a:xfrm>
-            <a:off x="4526280" y="2093976"/>
-            <a:ext cx="4297680" cy="731520"/>
+            <a:off x="4526280" y="2039112"/>
+            <a:ext cx="4297680" cy="768096"/>
           </a:xfrm>
           <a:prstGeom prst="rect">
             <a:avLst/>
@@ -7997,7 +7997,7 @@
                 <a:ea typeface="Calibri" pitchFamily="34" charset="-122"/>
                 <a:cs typeface="Calibri" pitchFamily="34" charset="-120"/>
               </a:rPr>
-              <a:t>聖詠旋律改編為新教眾讚歌（chorale）與聖公會聖歌；在天主教地區持續使用</a:t>
+              <a:t>聖詠旋律改編為新教眾讚歌（chorale）與聖公會聖歌</a:t>
             </a:r>
             <a:endParaRPr lang="en-US" sz="1400" dirty="0"/>
           </a:p>
@@ -8014,7 +8014,7 @@
                 <a:ea typeface="Calibri" pitchFamily="34" charset="-122"/>
                 <a:cs typeface="Calibri" pitchFamily="34" charset="-120"/>
               </a:rPr>
-              <a:t>Chant melodies adapted for Protestant chorales and Anglican hymns; still used in Catholic areas</a:t>
+              <a:t>Chant melodies adapted for Protestant chorales and Anglican hymns</a:t>
             </a:r>
             <a:endParaRPr lang="en-US" sz="1400" dirty="0"/>
           </a:p>
@@ -8028,7 +8028,7 @@
         </p:nvSpPr>
         <p:spPr>
           <a:xfrm>
-            <a:off x="274320" y="2962656"/>
+            <a:off x="274320" y="2916936"/>
             <a:ext cx="8595360" cy="841248"/>
           </a:xfrm>
           <a:prstGeom prst="rect">
@@ -8048,7 +8048,7 @@
         </p:nvSpPr>
         <p:spPr>
           <a:xfrm>
-            <a:off x="365760" y="3035808"/>
+            <a:off x="365760" y="2990088"/>
             <a:ext cx="685800" cy="694944"/>
           </a:xfrm>
           <a:prstGeom prst="rect">
@@ -8068,7 +8068,7 @@
         </p:nvSpPr>
         <p:spPr>
           <a:xfrm>
-            <a:off x="365760" y="3090672"/>
+            <a:off x="365760" y="3044952"/>
             <a:ext cx="685800" cy="594360"/>
           </a:xfrm>
           <a:prstGeom prst="rect">
@@ -8104,7 +8104,7 @@
         </p:nvSpPr>
         <p:spPr>
           <a:xfrm>
-            <a:off x="1188720" y="3026664"/>
+            <a:off x="1188720" y="2980944"/>
             <a:ext cx="3200400" cy="274320"/>
           </a:xfrm>
           <a:prstGeom prst="rect">
@@ -8143,7 +8143,7 @@
         </p:nvSpPr>
         <p:spPr>
           <a:xfrm>
-            <a:off x="1188720" y="3273552"/>
+            <a:off x="1188720" y="3227832"/>
             <a:ext cx="3200400" cy="228600"/>
           </a:xfrm>
           <a:prstGeom prst="rect">
@@ -8182,7 +8182,7 @@
         </p:nvSpPr>
         <p:spPr>
           <a:xfrm>
-            <a:off x="4434840" y="3072384"/>
+            <a:off x="4434840" y="3026664"/>
             <a:ext cx="27432" cy="621792"/>
           </a:xfrm>
           <a:prstGeom prst="rect">
@@ -8202,8 +8202,8 @@
         </p:nvSpPr>
         <p:spPr>
           <a:xfrm>
-            <a:off x="4526280" y="3035808"/>
-            <a:ext cx="4297680" cy="731520"/>
+            <a:off x="4526280" y="2971800"/>
+            <a:ext cx="4297680" cy="768096"/>
           </a:xfrm>
           <a:prstGeom prst="rect">
             <a:avLst/>
@@ -8227,7 +8227,7 @@
                 <a:ea typeface="Calibri" pitchFamily="34" charset="-122"/>
                 <a:cs typeface="Calibri" pitchFamily="34" charset="-120"/>
               </a:rPr>
-              <a:t>允許以地方語言舉行彌撒；拉丁聖詠不再是必須——從定期禮拜中幾近消失</a:t>
+              <a:t>允許以地方語言舉行彌撒；拉丁聖詠不再是必須</a:t>
             </a:r>
             <a:endParaRPr lang="en-US" sz="1400" dirty="0"/>
           </a:p>
@@ -8244,7 +8244,7 @@
                 <a:ea typeface="Calibri" pitchFamily="34" charset="-122"/>
                 <a:cs typeface="Calibri" pitchFamily="34" charset="-120"/>
               </a:rPr>
-              <a:t>Permitted vernacular Mass; Latin chant no longer required, virtually disappeared from regular services</a:t>
+              <a:t>Permitted vernacular Mass; Latin chant no longer required</a:t>
             </a:r>
             <a:endParaRPr lang="en-US" sz="1400" dirty="0"/>
           </a:p>
@@ -8258,7 +8258,7 @@
         </p:nvSpPr>
         <p:spPr>
           <a:xfrm>
-            <a:off x="274320" y="3904488"/>
+            <a:off x="274320" y="3849624"/>
             <a:ext cx="8595360" cy="841248"/>
           </a:xfrm>
           <a:prstGeom prst="rect">
@@ -8278,7 +8278,7 @@
         </p:nvSpPr>
         <p:spPr>
           <a:xfrm>
-            <a:off x="365760" y="3977640"/>
+            <a:off x="365760" y="3922776"/>
             <a:ext cx="685800" cy="694944"/>
           </a:xfrm>
           <a:prstGeom prst="rect">
@@ -8298,7 +8298,7 @@
         </p:nvSpPr>
         <p:spPr>
           <a:xfrm>
-            <a:off x="365760" y="4032504"/>
+            <a:off x="365760" y="3977640"/>
             <a:ext cx="685800" cy="594360"/>
           </a:xfrm>
           <a:prstGeom prst="rect">
@@ -8334,7 +8334,7 @@
         </p:nvSpPr>
         <p:spPr>
           <a:xfrm>
-            <a:off x="1188720" y="3968496"/>
+            <a:off x="1188720" y="3913632"/>
             <a:ext cx="3200400" cy="274320"/>
           </a:xfrm>
           <a:prstGeom prst="rect">
@@ -8373,7 +8373,7 @@
         </p:nvSpPr>
         <p:spPr>
           <a:xfrm>
-            <a:off x="1188720" y="4215384"/>
+            <a:off x="1188720" y="4160520"/>
             <a:ext cx="3200400" cy="228600"/>
           </a:xfrm>
           <a:prstGeom prst="rect">
@@ -8412,7 +8412,7 @@
         </p:nvSpPr>
         <p:spPr>
           <a:xfrm>
-            <a:off x="4434840" y="4014216"/>
+            <a:off x="4434840" y="3959352"/>
             <a:ext cx="27432" cy="621792"/>
           </a:xfrm>
           <a:prstGeom prst="rect">
@@ -8432,8 +8432,8 @@
         </p:nvSpPr>
         <p:spPr>
           <a:xfrm>
-            <a:off x="4526280" y="3977640"/>
-            <a:ext cx="4297680" cy="731520"/>
+            <a:off x="4526280" y="3904488"/>
+            <a:ext cx="4297680" cy="768096"/>
           </a:xfrm>
           <a:prstGeom prst="rect">
             <a:avLst/>
@@ -8457,7 +8457,7 @@
                 <a:ea typeface="Calibri" pitchFamily="34" charset="-122"/>
                 <a:cs typeface="Calibri" pitchFamily="34" charset="-120"/>
               </a:rPr>
-              <a:t>1993 Silos 修士《Chant》專輯歐洲暢銷冠軍；2008 Heiligenkreuz《Chant》全球熱銷；電玩《Halo》等使用聖詠風格</a:t>
+              <a:t>1993 Silos 修士《Chant》歐洲暢銷冠軍；電玩《Halo》使用聖詠風格</a:t>
             </a:r>
             <a:endParaRPr lang="en-US" sz="1400" dirty="0"/>
           </a:p>
@@ -8474,7 +8474,7 @@
                 <a:ea typeface="Calibri" pitchFamily="34" charset="-122"/>
                 <a:cs typeface="Calibri" pitchFamily="34" charset="-120"/>
               </a:rPr>
-              <a:t>1993 Chant album bestseller; 2008 Heiligenkreuz platinum; Halo uses chant style</a:t>
+              <a:t>1993 Chant album bestseller; Halo uses chant style</a:t>
             </a:r>
             <a:endParaRPr lang="en-US" sz="1400" dirty="0"/>
           </a:p>
@@ -8619,8 +8619,8 @@
         </p:nvSpPr>
         <p:spPr>
           <a:xfrm>
-            <a:off x="274320" y="822960"/>
-            <a:ext cx="8595360" cy="603504"/>
+            <a:off x="274320" y="804672"/>
+            <a:ext cx="8595360" cy="640080"/>
           </a:xfrm>
           <a:prstGeom prst="rect">
             <a:avLst/>
@@ -8675,8 +8675,8 @@
         </p:nvSpPr>
         <p:spPr>
           <a:xfrm>
-            <a:off x="960120" y="868680"/>
-            <a:ext cx="7772400" cy="530352"/>
+            <a:off x="960120" y="850392"/>
+            <a:ext cx="7772400" cy="566928"/>
           </a:xfrm>
           <a:prstGeom prst="rect">
             <a:avLst/>
@@ -8700,7 +8700,7 @@
                 <a:ea typeface="Calibri" pitchFamily="34" charset="-122"/>
                 <a:cs typeface="Calibri" pitchFamily="34" charset="-120"/>
               </a:rPr>
-              <a:t>羅馬禮儀的雙重目的：對上帝獻頌讚，對信徒傳教義；彌撒為中心，日課為日常</a:t>
+              <a:t>羅馬禮儀雙重目的：頌讚上帝 + 教導信徒；彌撒為中心，日課為日常</a:t>
             </a:r>
             <a:endParaRPr lang="en-US" sz="1400" dirty="0"/>
           </a:p>
@@ -8717,7 +8717,7 @@
                 <a:ea typeface="Calibri" pitchFamily="34" charset="-122"/>
                 <a:cs typeface="Calibri" pitchFamily="34" charset="-120"/>
               </a:rPr>
-              <a:t>Roman liturgy's dual aim: praise to God + instruction for worshippers; Mass central, Office daily</a:t>
+              <a:t>Roman liturgy: praise + instruction; Mass central, Office daily</a:t>
             </a:r>
             <a:endParaRPr lang="en-US" sz="1400" dirty="0"/>
           </a:p>
@@ -8731,8 +8731,8 @@
         </p:nvSpPr>
         <p:spPr>
           <a:xfrm>
-            <a:off x="274320" y="1527048"/>
-            <a:ext cx="8595360" cy="603504"/>
+            <a:off x="274320" y="1490472"/>
+            <a:ext cx="8595360" cy="640080"/>
           </a:xfrm>
           <a:prstGeom prst="rect">
             <a:avLst/>
@@ -8751,7 +8751,7 @@
         </p:nvSpPr>
         <p:spPr>
           <a:xfrm>
-            <a:off x="365760" y="1600200"/>
+            <a:off x="365760" y="1581912"/>
             <a:ext cx="502920" cy="457200"/>
           </a:xfrm>
           <a:prstGeom prst="rect">
@@ -8787,8 +8787,8 @@
         </p:nvSpPr>
         <p:spPr>
           <a:xfrm>
-            <a:off x="960120" y="1572768"/>
-            <a:ext cx="7772400" cy="530352"/>
+            <a:off x="960120" y="1536192"/>
+            <a:ext cx="7772400" cy="566928"/>
           </a:xfrm>
           <a:prstGeom prst="rect">
             <a:avLst/>
@@ -8812,7 +8812,7 @@
                 <a:ea typeface="Calibri" pitchFamily="34" charset="-122"/>
                 <a:cs typeface="Calibri" pitchFamily="34" charset="-120"/>
               </a:rPr>
-              <a:t>彌撒分為 Proper（隨日變動）與 Ordinary（固定不變）；音樂高潮為 Gradual、Alleluia、Offertory</a:t>
+              <a:t>彌撒分 Proper（隨日變）與 Ordinary（固定）；音樂高潮為 Gradual、Alleluia、Offertory</a:t>
             </a:r>
             <a:endParaRPr lang="en-US" sz="1400" dirty="0"/>
           </a:p>
@@ -8829,7 +8829,7 @@
                 <a:ea typeface="Calibri" pitchFamily="34" charset="-122"/>
                 <a:cs typeface="Calibri" pitchFamily="34" charset="-120"/>
               </a:rPr>
-              <a:t>Mass = Proper (varies) + Ordinary (fixed); musical peaks: Gradual, Alleluia, Offertory</a:t>
+              <a:t>Mass = Proper (varies) + Ordinary (fixed); peaks: Gradual, Alleluia, Offertory</a:t>
             </a:r>
             <a:endParaRPr lang="en-US" sz="1400" dirty="0"/>
           </a:p>
@@ -8843,8 +8843,8 @@
         </p:nvSpPr>
         <p:spPr>
           <a:xfrm>
-            <a:off x="274320" y="2231136"/>
-            <a:ext cx="8595360" cy="603504"/>
+            <a:off x="274320" y="2176272"/>
+            <a:ext cx="8595360" cy="640080"/>
           </a:xfrm>
           <a:prstGeom prst="rect">
             <a:avLst/>
@@ -8863,7 +8863,7 @@
         </p:nvSpPr>
         <p:spPr>
           <a:xfrm>
-            <a:off x="365760" y="2304288"/>
+            <a:off x="365760" y="2267712"/>
             <a:ext cx="502920" cy="457200"/>
           </a:xfrm>
           <a:prstGeom prst="rect">
@@ -8899,8 +8899,8 @@
         </p:nvSpPr>
         <p:spPr>
           <a:xfrm>
-            <a:off x="960120" y="2276856"/>
-            <a:ext cx="7772400" cy="530352"/>
+            <a:off x="960120" y="2221992"/>
+            <a:ext cx="7772400" cy="566928"/>
           </a:xfrm>
           <a:prstGeom prst="rect">
             <a:avLst/>
@@ -8924,7 +8924,7 @@
                 <a:ea typeface="Calibri" pitchFamily="34" charset="-122"/>
                 <a:cs typeface="Calibri" pitchFamily="34" charset="-120"/>
               </a:rPr>
-              <a:t>聖詠依演唱方式分 responsorial/antiphonal/direct，依歌詞設定分 syllabic/neumatic/melismatic</a:t>
+              <a:t>聖詠依演唱分 responsorial/antiphonal/direct；依歌詞分 syllabic/neumatic/melismatic</a:t>
             </a:r>
             <a:endParaRPr lang="en-US" sz="1400" dirty="0"/>
           </a:p>
@@ -8941,7 +8941,7 @@
                 <a:ea typeface="Calibri" pitchFamily="34" charset="-122"/>
                 <a:cs typeface="Calibri" pitchFamily="34" charset="-120"/>
               </a:rPr>
-              <a:t>Chants classified by performance (responsorial/antiphonal/direct) and text setting (syllabic/neumatic/melismatic)</a:t>
+              <a:t>Chants by performance (resp./antiph./direct) and text setting (syll./neum./melism.)</a:t>
             </a:r>
             <a:endParaRPr lang="en-US" sz="1400" dirty="0"/>
           </a:p>
@@ -8955,8 +8955,8 @@
         </p:nvSpPr>
         <p:spPr>
           <a:xfrm>
-            <a:off x="274320" y="2935224"/>
-            <a:ext cx="8595360" cy="603504"/>
+            <a:off x="274320" y="2862072"/>
+            <a:ext cx="8595360" cy="640080"/>
           </a:xfrm>
           <a:prstGeom prst="rect">
             <a:avLst/>
@@ -8975,7 +8975,7 @@
         </p:nvSpPr>
         <p:spPr>
           <a:xfrm>
-            <a:off x="365760" y="3008376"/>
+            <a:off x="365760" y="2953512"/>
             <a:ext cx="502920" cy="457200"/>
           </a:xfrm>
           <a:prstGeom prst="rect">
@@ -9011,8 +9011,8 @@
         </p:nvSpPr>
         <p:spPr>
           <a:xfrm>
-            <a:off x="960120" y="2980944"/>
-            <a:ext cx="7772400" cy="530352"/>
+            <a:off x="960120" y="2907792"/>
+            <a:ext cx="7772400" cy="566928"/>
           </a:xfrm>
           <a:prstGeom prst="rect">
             <a:avLst/>
@@ -9036,7 +9036,7 @@
                 <a:ea typeface="Calibri" pitchFamily="34" charset="-122"/>
                 <a:cs typeface="Calibri" pitchFamily="34" charset="-120"/>
               </a:rPr>
-              <a:t>Trope（增飾）與 Sequence（繼抒詠）是 9–12 世紀創作的出口，在授權聖詠的「邊緣」發揮創意</a:t>
+              <a:t>Trope 與 Sequence 是 9–12 世紀在授權聖詠「邊緣」的創作出口</a:t>
             </a:r>
             <a:endParaRPr lang="en-US" sz="1400" dirty="0"/>
           </a:p>
@@ -9053,7 +9053,7 @@
                 <a:ea typeface="Calibri" pitchFamily="34" charset="-122"/>
                 <a:cs typeface="Calibri" pitchFamily="34" charset="-120"/>
               </a:rPr>
-              <a:t>Tropes and sequences gave 9–12 c. musicians creative outlets in the margins of the authorized repertory</a:t>
+              <a:t>Tropes and sequences gave 9–12 c. creative outlets in the chant margins</a:t>
             </a:r>
             <a:endParaRPr lang="en-US" sz="1400" dirty="0"/>
           </a:p>
@@ -9067,8 +9067,8 @@
         </p:nvSpPr>
         <p:spPr>
           <a:xfrm>
-            <a:off x="274320" y="3639312"/>
-            <a:ext cx="8595360" cy="603504"/>
+            <a:off x="274320" y="3547872"/>
+            <a:ext cx="8595360" cy="640080"/>
           </a:xfrm>
           <a:prstGeom prst="rect">
             <a:avLst/>
@@ -9087,7 +9087,7 @@
         </p:nvSpPr>
         <p:spPr>
           <a:xfrm>
-            <a:off x="365760" y="3712464"/>
+            <a:off x="365760" y="3639312"/>
             <a:ext cx="502920" cy="457200"/>
           </a:xfrm>
           <a:prstGeom prst="rect">
@@ -9123,8 +9123,8 @@
         </p:nvSpPr>
         <p:spPr>
           <a:xfrm>
-            <a:off x="960120" y="3685032"/>
-            <a:ext cx="7772400" cy="530352"/>
+            <a:off x="960120" y="3593592"/>
+            <a:ext cx="7772400" cy="566928"/>
           </a:xfrm>
           <a:prstGeom prst="rect">
             <a:avLst/>
@@ -9148,7 +9148,7 @@
                 <a:ea typeface="Calibri" pitchFamily="34" charset="-122"/>
                 <a:cs typeface="Calibri" pitchFamily="34" charset="-120"/>
               </a:rPr>
-              <a:t>禮儀劇由對話型 trope 發展而來（如 Quem queritis in sepulchro）；由神職人員在教堂內演出</a:t>
+              <a:t>禮儀劇由對話型 trope 發展而來（如 Quem queritis in sepulchro），由神職人員演出</a:t>
             </a:r>
             <a:endParaRPr lang="en-US" sz="1400" dirty="0"/>
           </a:p>
@@ -9165,7 +9165,7 @@
                 <a:ea typeface="Calibri" pitchFamily="34" charset="-122"/>
                 <a:cs typeface="Calibri" pitchFamily="34" charset="-120"/>
               </a:rPr>
-              <a:t>Liturgical drama grew from dialogue tropes (Quem queritis in sepulchro); performed in church by clergy</a:t>
+              <a:t>Liturgical drama grew from dialogue tropes; performed in church by clergy</a:t>
             </a:r>
             <a:endParaRPr lang="en-US" sz="1400" dirty="0"/>
           </a:p>
@@ -9179,8 +9179,8 @@
         </p:nvSpPr>
         <p:spPr>
           <a:xfrm>
-            <a:off x="274320" y="4343400"/>
-            <a:ext cx="8595360" cy="603504"/>
+            <a:off x="274320" y="4233672"/>
+            <a:ext cx="8595360" cy="640080"/>
           </a:xfrm>
           <a:prstGeom prst="rect">
             <a:avLst/>
@@ -9199,7 +9199,7 @@
         </p:nvSpPr>
         <p:spPr>
           <a:xfrm>
-            <a:off x="365760" y="4416552"/>
+            <a:off x="365760" y="4325112"/>
             <a:ext cx="502920" cy="457200"/>
           </a:xfrm>
           <a:prstGeom prst="rect">
@@ -9235,8 +9235,8 @@
         </p:nvSpPr>
         <p:spPr>
           <a:xfrm>
-            <a:off x="960120" y="4389120"/>
-            <a:ext cx="7772400" cy="530352"/>
+            <a:off x="960120" y="4279392"/>
+            <a:ext cx="7772400" cy="566928"/>
           </a:xfrm>
           <a:prstGeom prst="rect">
             <a:avLst/>
@@ -9260,7 +9260,7 @@
                 <a:ea typeface="Calibri" pitchFamily="34" charset="-122"/>
                 <a:cs typeface="Calibri" pitchFamily="34" charset="-120"/>
               </a:rPr>
-              <a:t>Hildegard of Bingen 是中世紀留下最多聖詠的作曲家，也是第一位留下完整音樂劇（Ordo virtutum）的女性</a:t>
+              <a:t>Hildegard of Bingen：留下最多聖詠的中世紀作曲家；Ordo virtutum 為現存最早音樂劇</a:t>
             </a:r>
             <a:endParaRPr lang="en-US" sz="1400" dirty="0"/>
           </a:p>
@@ -9277,7 +9277,7 @@
                 <a:ea typeface="Calibri" pitchFamily="34" charset="-122"/>
                 <a:cs typeface="Calibri" pitchFamily="34" charset="-120"/>
               </a:rPr>
-              <a:t>Hildegard left more chants than any medieval composer; her Ordo virtutum is the earliest surviving non-liturgical music drama</a:t>
+              <a:t>Hildegard: most medieval chants; Ordo virtutum = earliest music drama</a:t>
             </a:r>
             <a:endParaRPr lang="en-US" sz="1400" dirty="0"/>
           </a:p>
@@ -11711,7 +11711,7 @@
         <p:spPr>
           <a:xfrm>
             <a:off x="274320" y="1097280"/>
-            <a:ext cx="4206240" cy="3657600"/>
+            <a:ext cx="4206240" cy="3566160"/>
           </a:xfrm>
           <a:prstGeom prst="rect">
             <a:avLst/>
@@ -12031,7 +12031,7 @@
         <p:spPr>
           <a:xfrm>
             <a:off x="4663440" y="1097280"/>
-            <a:ext cx="4206240" cy="3657600"/>
+            <a:ext cx="4206240" cy="3566160"/>
           </a:xfrm>
           <a:prstGeom prst="rect">
             <a:avLst/>
@@ -12359,17 +12359,17 @@
         </p:nvSpPr>
         <p:spPr>
           <a:xfrm>
-            <a:off x="365760" y="4809744"/>
-            <a:ext cx="8412480" cy="201168"/>
-          </a:xfrm>
-          <a:prstGeom prst="rect">
-            <a:avLst/>
-          </a:prstGeom>
-          <a:noFill/>
-          <a:ln/>
-        </p:spPr>
-        <p:txBody>
-          <a:bodyPr wrap="square" rtlCol="0" anchor="t"/>
+            <a:off x="365760" y="4736592"/>
+            <a:ext cx="8412480" cy="256032"/>
+          </a:xfrm>
+          <a:prstGeom prst="rect">
+            <a:avLst/>
+          </a:prstGeom>
+          <a:noFill/>
+          <a:ln/>
+        </p:spPr>
+        <p:txBody>
+          <a:bodyPr wrap="square" lIns="0" tIns="0" rIns="0" bIns="0" rtlCol="0" anchor="t"/>
           <a:lstStyle/>
           <a:p>
             <a:pPr algn="ctr" indent="0" marL="0">
@@ -16562,8 +16562,8 @@
         </p:nvSpPr>
         <p:spPr>
           <a:xfrm>
-            <a:off x="274320" y="1097280"/>
-            <a:ext cx="8595360" cy="548640"/>
+            <a:off x="274320" y="1051560"/>
+            <a:ext cx="8595360" cy="603504"/>
           </a:xfrm>
           <a:prstGeom prst="rect">
             <a:avLst/>
@@ -16582,8 +16582,8 @@
         </p:nvSpPr>
         <p:spPr>
           <a:xfrm>
-            <a:off x="411480" y="1143000"/>
-            <a:ext cx="1920240" cy="457200"/>
+            <a:off x="365760" y="1106424"/>
+            <a:ext cx="1920240" cy="530352"/>
           </a:xfrm>
           <a:prstGeom prst="rect">
             <a:avLst/>
@@ -16621,8 +16621,8 @@
         </p:nvSpPr>
         <p:spPr>
           <a:xfrm>
-            <a:off x="2331720" y="1143000"/>
-            <a:ext cx="1737360" cy="475488"/>
+            <a:off x="2331720" y="1106424"/>
+            <a:ext cx="1371600" cy="530352"/>
           </a:xfrm>
           <a:prstGeom prst="rect">
             <a:avLst/>
@@ -16677,8 +16677,8 @@
         </p:nvSpPr>
         <p:spPr>
           <a:xfrm>
-            <a:off x="4114800" y="1188720"/>
-            <a:ext cx="22860" cy="384048"/>
+            <a:off x="3749040" y="1143000"/>
+            <a:ext cx="22860" cy="457200"/>
           </a:xfrm>
           <a:prstGeom prst="rect">
             <a:avLst/>
@@ -16697,8 +16697,8 @@
         </p:nvSpPr>
         <p:spPr>
           <a:xfrm>
-            <a:off x="4206240" y="1133856"/>
-            <a:ext cx="4617720" cy="502920"/>
+            <a:off x="3840480" y="1088136"/>
+            <a:ext cx="4937760" cy="566928"/>
           </a:xfrm>
           <a:prstGeom prst="rect">
             <a:avLst/>
@@ -16722,7 +16722,7 @@
                 <a:ea typeface="Calibri" pitchFamily="34" charset="-122"/>
                 <a:cs typeface="Calibri" pitchFamily="34" charset="-120"/>
               </a:rPr>
-              <a:t>開堂遊行時由唱詩班唱 · 對唱歌 + 一詩節 + 小聖三頌</a:t>
+              <a:t>開堂遊行；對唱歌 + 一詩節 + 小聖三頌</a:t>
             </a:r>
             <a:endParaRPr lang="en-US" sz="1400" dirty="0"/>
           </a:p>
@@ -16739,7 +16739,7 @@
                 <a:ea typeface="Calibri" pitchFamily="34" charset="-122"/>
                 <a:cs typeface="Calibri" pitchFamily="34" charset="-120"/>
               </a:rPr>
-              <a:t>Entrance chant — antiphon + psalm verse + Lesser Doxology</a:t>
+              <a:t>Entrance chant — antiphon + verse + Doxology</a:t>
             </a:r>
             <a:endParaRPr lang="en-US" sz="1400" dirty="0"/>
           </a:p>
@@ -16753,8 +16753,8 @@
         </p:nvSpPr>
         <p:spPr>
           <a:xfrm>
-            <a:off x="274320" y="1709928"/>
-            <a:ext cx="8595360" cy="548640"/>
+            <a:off x="274320" y="1691640"/>
+            <a:ext cx="8595360" cy="603504"/>
           </a:xfrm>
           <a:prstGeom prst="rect">
             <a:avLst/>
@@ -16773,8 +16773,8 @@
         </p:nvSpPr>
         <p:spPr>
           <a:xfrm>
-            <a:off x="411480" y="1755648"/>
-            <a:ext cx="1920240" cy="457200"/>
+            <a:off x="365760" y="1746504"/>
+            <a:ext cx="1920240" cy="530352"/>
           </a:xfrm>
           <a:prstGeom prst="rect">
             <a:avLst/>
@@ -16812,8 +16812,8 @@
         </p:nvSpPr>
         <p:spPr>
           <a:xfrm>
-            <a:off x="2331720" y="1755648"/>
-            <a:ext cx="1737360" cy="475488"/>
+            <a:off x="2331720" y="1746504"/>
+            <a:ext cx="1371600" cy="530352"/>
           </a:xfrm>
           <a:prstGeom prst="rect">
             <a:avLst/>
@@ -16868,8 +16868,8 @@
         </p:nvSpPr>
         <p:spPr>
           <a:xfrm>
-            <a:off x="4114800" y="1801368"/>
-            <a:ext cx="22860" cy="384048"/>
+            <a:off x="3749040" y="1783080"/>
+            <a:ext cx="22860" cy="457200"/>
           </a:xfrm>
           <a:prstGeom prst="rect">
             <a:avLst/>
@@ -16888,8 +16888,8 @@
         </p:nvSpPr>
         <p:spPr>
           <a:xfrm>
-            <a:off x="4206240" y="1746504"/>
-            <a:ext cx="4617720" cy="502920"/>
+            <a:off x="3840480" y="1728216"/>
+            <a:ext cx="4937760" cy="566928"/>
           </a:xfrm>
           <a:prstGeom prst="rect">
             <a:avLst/>
@@ -16913,7 +16913,7 @@
                 <a:ea typeface="Calibri" pitchFamily="34" charset="-122"/>
                 <a:cs typeface="Calibri" pitchFamily="34" charset="-120"/>
               </a:rPr>
-              <a:t>領聖體時演唱 · 後來縮短為僅對唱歌</a:t>
+              <a:t>領聖體時演唱；後縮短為僅對唱歌</a:t>
             </a:r>
             <a:endParaRPr lang="en-US" sz="1400" dirty="0"/>
           </a:p>
@@ -16930,7 +16930,7 @@
                 <a:ea typeface="Calibri" pitchFamily="34" charset="-122"/>
                 <a:cs typeface="Calibri" pitchFamily="34" charset="-120"/>
               </a:rPr>
-              <a:t>Sung during communion; eventually shortened to antiphon only</a:t>
+              <a:t>Sung at communion; later antiphon only</a:t>
             </a:r>
             <a:endParaRPr lang="en-US" sz="1400" dirty="0"/>
           </a:p>
@@ -16944,8 +16944,8 @@
         </p:nvSpPr>
         <p:spPr>
           <a:xfrm>
-            <a:off x="274320" y="2322576"/>
-            <a:ext cx="8595360" cy="548640"/>
+            <a:off x="274320" y="2331720"/>
+            <a:ext cx="8595360" cy="603504"/>
           </a:xfrm>
           <a:prstGeom prst="rect">
             <a:avLst/>
@@ -16964,8 +16964,8 @@
         </p:nvSpPr>
         <p:spPr>
           <a:xfrm>
-            <a:off x="411480" y="2368296"/>
-            <a:ext cx="1920240" cy="457200"/>
+            <a:off x="365760" y="2386584"/>
+            <a:ext cx="1920240" cy="530352"/>
           </a:xfrm>
           <a:prstGeom prst="rect">
             <a:avLst/>
@@ -17003,8 +17003,8 @@
         </p:nvSpPr>
         <p:spPr>
           <a:xfrm>
-            <a:off x="2331720" y="2368296"/>
-            <a:ext cx="1737360" cy="475488"/>
+            <a:off x="2331720" y="2386584"/>
+            <a:ext cx="1371600" cy="530352"/>
           </a:xfrm>
           <a:prstGeom prst="rect">
             <a:avLst/>
@@ -17059,8 +17059,8 @@
         </p:nvSpPr>
         <p:spPr>
           <a:xfrm>
-            <a:off x="4114800" y="2414016"/>
-            <a:ext cx="22860" cy="384048"/>
+            <a:off x="3749040" y="2423160"/>
+            <a:ext cx="22860" cy="457200"/>
           </a:xfrm>
           <a:prstGeom prst="rect">
             <a:avLst/>
@@ -17079,8 +17079,8 @@
         </p:nvSpPr>
         <p:spPr>
           <a:xfrm>
-            <a:off x="4206240" y="2359152"/>
-            <a:ext cx="4617720" cy="502920"/>
+            <a:off x="3840480" y="2368296"/>
+            <a:ext cx="4937760" cy="566928"/>
           </a:xfrm>
           <a:prstGeom prst="rect">
             <a:avLst/>
@@ -17104,7 +17104,7 @@
                 <a:ea typeface="Calibri" pitchFamily="34" charset="-122"/>
                 <a:cs typeface="Calibri" pitchFamily="34" charset="-120"/>
               </a:rPr>
-              <a:t>書信誦讀之後 · 以階梯（gradus）得名 · 獨唱者 + 唱詩班</a:t>
+              <a:t>書信之後；以階梯 gradus 得名；獨唱 + 唱詩班</a:t>
             </a:r>
             <a:endParaRPr lang="en-US" sz="1400" dirty="0"/>
           </a:p>
@@ -17121,7 +17121,7 @@
                 <a:ea typeface="Calibri" pitchFamily="34" charset="-122"/>
                 <a:cs typeface="Calibri" pitchFamily="34" charset="-120"/>
               </a:rPr>
-              <a:t>After Epistle; named from the stair (gradus); soloist + choir</a:t>
+              <a:t>After Epistle; named from gradus; soloist + choir</a:t>
             </a:r>
             <a:endParaRPr lang="en-US" sz="1400" dirty="0"/>
           </a:p>
@@ -17135,8 +17135,8 @@
         </p:nvSpPr>
         <p:spPr>
           <a:xfrm>
-            <a:off x="274320" y="2935224"/>
-            <a:ext cx="8595360" cy="548640"/>
+            <a:off x="274320" y="2971800"/>
+            <a:ext cx="8595360" cy="603504"/>
           </a:xfrm>
           <a:prstGeom prst="rect">
             <a:avLst/>
@@ -17155,8 +17155,8 @@
         </p:nvSpPr>
         <p:spPr>
           <a:xfrm>
-            <a:off x="411480" y="2980944"/>
-            <a:ext cx="1920240" cy="457200"/>
+            <a:off x="365760" y="3026664"/>
+            <a:ext cx="1920240" cy="530352"/>
           </a:xfrm>
           <a:prstGeom prst="rect">
             <a:avLst/>
@@ -17194,8 +17194,8 @@
         </p:nvSpPr>
         <p:spPr>
           <a:xfrm>
-            <a:off x="2331720" y="2980944"/>
-            <a:ext cx="1737360" cy="475488"/>
+            <a:off x="2331720" y="3026664"/>
+            <a:ext cx="1371600" cy="530352"/>
           </a:xfrm>
           <a:prstGeom prst="rect">
             <a:avLst/>
@@ -17250,8 +17250,8 @@
         </p:nvSpPr>
         <p:spPr>
           <a:xfrm>
-            <a:off x="4114800" y="3026664"/>
-            <a:ext cx="22860" cy="384048"/>
+            <a:off x="3749040" y="3063240"/>
+            <a:ext cx="22860" cy="457200"/>
           </a:xfrm>
           <a:prstGeom prst="rect">
             <a:avLst/>
@@ -17270,8 +17270,8 @@
         </p:nvSpPr>
         <p:spPr>
           <a:xfrm>
-            <a:off x="4206240" y="2971800"/>
-            <a:ext cx="4617720" cy="502920"/>
+            <a:off x="3840480" y="3008376"/>
+            <a:ext cx="4937760" cy="566928"/>
           </a:xfrm>
           <a:prstGeom prst="rect">
             <a:avLst/>
@@ -17295,7 +17295,7 @@
                 <a:ea typeface="Calibri" pitchFamily="34" charset="-122"/>
                 <a:cs typeface="Calibri" pitchFamily="34" charset="-120"/>
               </a:rPr>
-              <a:t>「alleluia」的最後音節延伸為「jubilus」長花腔——「言語無法表達的喜悅」</a:t>
+              <a:t>最後音節延伸為「jubilus」長花腔——言語無法表達的喜悅</a:t>
             </a:r>
             <a:endParaRPr lang="en-US" sz="1400" dirty="0"/>
           </a:p>
@@ -17312,7 +17312,7 @@
                 <a:ea typeface="Calibri" pitchFamily="34" charset="-122"/>
                 <a:cs typeface="Calibri" pitchFamily="34" charset="-120"/>
               </a:rPr>
-              <a:t>Extended jubilus melisma on final syllable: "joy beyond words"</a:t>
+              <a:t>Jubilus melisma on final syllable: "joy beyond words"</a:t>
             </a:r>
             <a:endParaRPr lang="en-US" sz="1400" dirty="0"/>
           </a:p>
@@ -17326,8 +17326,8 @@
         </p:nvSpPr>
         <p:spPr>
           <a:xfrm>
-            <a:off x="274320" y="3547872"/>
-            <a:ext cx="8595360" cy="548640"/>
+            <a:off x="274320" y="3611880"/>
+            <a:ext cx="8595360" cy="603504"/>
           </a:xfrm>
           <a:prstGeom prst="rect">
             <a:avLst/>
@@ -17346,8 +17346,8 @@
         </p:nvSpPr>
         <p:spPr>
           <a:xfrm>
-            <a:off x="411480" y="3593592"/>
-            <a:ext cx="1920240" cy="457200"/>
+            <a:off x="365760" y="3666744"/>
+            <a:ext cx="1920240" cy="530352"/>
           </a:xfrm>
           <a:prstGeom prst="rect">
             <a:avLst/>
@@ -17385,8 +17385,8 @@
         </p:nvSpPr>
         <p:spPr>
           <a:xfrm>
-            <a:off x="2331720" y="3593592"/>
-            <a:ext cx="1737360" cy="475488"/>
+            <a:off x="2331720" y="3666744"/>
+            <a:ext cx="1371600" cy="530352"/>
           </a:xfrm>
           <a:prstGeom prst="rect">
             <a:avLst/>
@@ -17441,8 +17441,8 @@
         </p:nvSpPr>
         <p:spPr>
           <a:xfrm>
-            <a:off x="4114800" y="3639312"/>
-            <a:ext cx="22860" cy="384048"/>
+            <a:off x="3749040" y="3703320"/>
+            <a:ext cx="22860" cy="457200"/>
           </a:xfrm>
           <a:prstGeom prst="rect">
             <a:avLst/>
@@ -17461,8 +17461,8 @@
         </p:nvSpPr>
         <p:spPr>
           <a:xfrm>
-            <a:off x="4206240" y="3584448"/>
-            <a:ext cx="4617720" cy="502920"/>
+            <a:off x="3840480" y="3648456"/>
+            <a:ext cx="4937760" cy="566928"/>
           </a:xfrm>
           <a:prstGeom prst="rect">
             <a:avLst/>
@@ -17486,7 +17486,7 @@
                 <a:ea typeface="Calibri" pitchFamily="34" charset="-122"/>
                 <a:cs typeface="Calibri" pitchFamily="34" charset="-120"/>
               </a:rPr>
-              <a:t>大齋期中取代 Alleluia · 最長的聖詠，僅限 mode 2 或 8</a:t>
+              <a:t>大齋期取代 Alleluia；最長的聖詠，僅限 mode 2 或 8</a:t>
             </a:r>
             <a:endParaRPr lang="en-US" sz="1400" dirty="0"/>
           </a:p>
@@ -17503,7 +17503,7 @@
                 <a:ea typeface="Calibri" pitchFamily="34" charset="-122"/>
                 <a:cs typeface="Calibri" pitchFamily="34" charset="-120"/>
               </a:rPr>
-              <a:t>Replaces Alleluia in Lent; longest chants, only in modes 2 or 8</a:t>
+              <a:t>Replaces Alleluia in Lent; longest, modes 2 or 8 only</a:t>
             </a:r>
             <a:endParaRPr lang="en-US" sz="1400" dirty="0"/>
           </a:p>
@@ -17517,8 +17517,8 @@
         </p:nvSpPr>
         <p:spPr>
           <a:xfrm>
-            <a:off x="274320" y="4160520"/>
-            <a:ext cx="8595360" cy="548640"/>
+            <a:off x="274320" y="4251960"/>
+            <a:ext cx="8595360" cy="603504"/>
           </a:xfrm>
           <a:prstGeom prst="rect">
             <a:avLst/>
@@ -17537,8 +17537,8 @@
         </p:nvSpPr>
         <p:spPr>
           <a:xfrm>
-            <a:off x="411480" y="4206240"/>
-            <a:ext cx="1920240" cy="457200"/>
+            <a:off x="365760" y="4306824"/>
+            <a:ext cx="1920240" cy="530352"/>
           </a:xfrm>
           <a:prstGeom prst="rect">
             <a:avLst/>
@@ -17576,8 +17576,8 @@
         </p:nvSpPr>
         <p:spPr>
           <a:xfrm>
-            <a:off x="2331720" y="4206240"/>
-            <a:ext cx="1737360" cy="475488"/>
+            <a:off x="2331720" y="4306824"/>
+            <a:ext cx="1371600" cy="530352"/>
           </a:xfrm>
           <a:prstGeom prst="rect">
             <a:avLst/>
@@ -17632,8 +17632,8 @@
         </p:nvSpPr>
         <p:spPr>
           <a:xfrm>
-            <a:off x="4114800" y="4251960"/>
-            <a:ext cx="22860" cy="384048"/>
+            <a:off x="3749040" y="4343400"/>
+            <a:ext cx="22860" cy="457200"/>
           </a:xfrm>
           <a:prstGeom prst="rect">
             <a:avLst/>
@@ -17652,8 +17652,8 @@
         </p:nvSpPr>
         <p:spPr>
           <a:xfrm>
-            <a:off x="4206240" y="4197096"/>
-            <a:ext cx="4617720" cy="502920"/>
+            <a:off x="3840480" y="4288536"/>
+            <a:ext cx="4937760" cy="566928"/>
           </a:xfrm>
           <a:prstGeom prst="rect">
             <a:avLst/>
@@ -17677,7 +17677,7 @@
                 <a:ea typeface="Calibri" pitchFamily="34" charset="-122"/>
                 <a:cs typeface="Calibri" pitchFamily="34" charset="-120"/>
               </a:rPr>
-              <a:t>神父預備餅酒時演唱 · 如 Gradual 般華麗</a:t>
+              <a:t>預備餅酒時演唱；如 Gradual 般華麗</a:t>
             </a:r>
             <a:endParaRPr lang="en-US" sz="1400" dirty="0"/>
           </a:p>
@@ -17694,7 +17694,7 @@
                 <a:ea typeface="Calibri" pitchFamily="34" charset="-122"/>
                 <a:cs typeface="Calibri" pitchFamily="34" charset="-120"/>
               </a:rPr>
-              <a:t>During the offering of bread and wine; as melismatic as Graduals</a:t>
+              <a:t>During offering of bread and wine; melismatic</a:t>
             </a:r>
             <a:endParaRPr lang="en-US" sz="1400" dirty="0"/>
           </a:p>

</xml_diff>